<commit_message>
docs(srs1): point the presentation at main after the merge
The closing slide and the Moodle comment now name main at 86b0ed7,
the merge of the authentication work.
</commit_message>
<xml_diff>
--- a/docs/srs1/СРС1_Тугельбаев_Алибек_4ТМ.pptx
+++ b/docs/srs1/СРС1_Тугельбаев_Алибек_4ТМ.pptx
@@ -126,7 +126,7 @@
   <p:extLst>
     <p:ext uri="{521415D9-36F7-43E2-AB2F-B90AF26B5E84}">
       <p14:sectionLst xmlns:p14="http://schemas.microsoft.com/office/powerpoint/2010/main">
-        <p14:section name="Введение" id="{95690ba8-f64f-436d-d8fe-93f50947b495}">
+        <p14:section name="Введение" id="{d01bc1f9-7a9c-d706-799c-a26aab7f4a87}">
           <p14:sldIdLst>
             <p14:sldId id="256"/>
             <p14:sldId id="257"/>
@@ -134,21 +134,21 @@
             <p14:sldId id="259"/>
           </p14:sldIdLst>
         </p14:section>
-        <p14:section name="Архитектура" id="{2f85ebdc-ed2d-35e6-fda9-b4aedaedf51d}">
+        <p14:section name="Архитектура" id="{d8d3ba4b-c4b7-c4b3-30e6-0cb89bccbeaa}">
           <p14:sldIdLst>
             <p14:sldId id="260"/>
             <p14:sldId id="261"/>
             <p14:sldId id="262"/>
           </p14:sldIdLst>
         </p14:section>
-        <p14:section name="Модель данных" id="{db9c3784-5dce-d3eb-1c25-98997909bf87}">
+        <p14:section name="Модель данных" id="{dbf0a404-472c-74e0-76dc-24f4c16eed5d}">
           <p14:sldIdLst>
             <p14:sldId id="263"/>
             <p14:sldId id="264"/>
             <p14:sldId id="265"/>
           </p14:sldIdLst>
         </p14:section>
-        <p14:section name="API" id="{ce1ad9ce-78c6-95df-8c38-5677e5ac7c3d}">
+        <p14:section name="API" id="{206bece9-52cb-ed52-32ac-9f87ad68c9c6}">
           <p14:sldIdLst>
             <p14:sldId id="266"/>
             <p14:sldId id="267"/>
@@ -156,7 +156,7 @@
             <p14:sldId id="269"/>
           </p14:sldIdLst>
         </p14:section>
-        <p14:section name="Безопасность" id="{009d9611-9c8f-9f0d-9d7b-2f1d33989f8e}">
+        <p14:section name="Безопасность" id="{814a1b63-d9a5-613a-1804-ffeb42557b08}">
           <p14:sldIdLst>
             <p14:sldId id="270"/>
             <p14:sldId id="271"/>
@@ -164,7 +164,7 @@
             <p14:sldId id="273"/>
           </p14:sldIdLst>
         </p14:section>
-        <p14:section name="Итоги" id="{5b52279e-6d2c-1a97-bc34-61392ff820c1}">
+        <p14:section name="Итоги" id="{c6d49c46-4952-6899-ebf1-5093e5b08b5a}">
           <p14:sldIdLst>
             <p14:sldId id="274"/>
             <p14:sldId id="275"/>
@@ -15966,7 +15966,7 @@
                   <a:schemeClr val="bg2"/>
                 </a:solidFill>
               </a:rPr>
-              <a:t>  ·  ветка feat/profile-auth, коммит 15255c2</a:t>
+              <a:t>  ·  ветка main, коммит 86b0ed7</a:t>
             </a:r>
             <a:endParaRPr lang="en-US" sz="1800" dirty="0"/>
           </a:p>

</xml_diff>